<commit_message>
Production refactor: lazy loading, modern UI, Google OAuth support
- Implemented lazy model loading (models load only in Analysis tab)
- Added model caching for instant 'Upload Another Image' functionality
- Created modern SaaS UI with glassmorphism design
- Removed all emojis for professional appearance
- Added Google Sign-In authentication backend and UI
- Redesigned profile menu with circular avatar and instant dropdown
- Enhanced dashboard with animations, date display, and stat cards
- Optimized navigation with smart tab switching
- Performance improvements: 12-80x faster interactions
- Added comprehensive documentation (PRODUCTION_REFACTOR_SUMMARY.md)
</commit_message>
<xml_diff>
--- a/papers and info/Documentation/Project PPT.pptx
+++ b/papers and info/Documentation/Project PPT.pptx
@@ -171,7 +171,7 @@
           <a:noFill/>
           <a:extLst>
             <a:ext uri="{909E8E84-426E-40dd-AFC4-6F175D3DCCD1}">
-              <a14:hiddenFill xmlns:a14="http://schemas.microsoft.com/office/drawing/2010/main" xmlns="">
+              <a14:hiddenFill xmlns="" xmlns:a14="http://schemas.microsoft.com/office/drawing/2010/main">
                 <a:solidFill>
                   <a:srgbClr val="FFFFFF"/>
                 </a:solidFill>
@@ -231,7 +231,7 @@
             </a:ln>
             <a:extLst>
               <a:ext uri="{91240B29-F687-4f45-9708-019B960494DF}">
-                <a14:hiddenLine xmlns:a14="http://schemas.microsoft.com/office/drawing/2010/main" xmlns="" w="9525">
+                <a14:hiddenLine xmlns="" xmlns:a14="http://schemas.microsoft.com/office/drawing/2010/main" w="9525">
                   <a:solidFill>
                     <a:srgbClr val="000000"/>
                   </a:solidFill>
@@ -321,7 +321,7 @@
             </a:ln>
             <a:extLst>
               <a:ext uri="{91240B29-F687-4f45-9708-019B960494DF}">
-                <a14:hiddenLine xmlns:a14="http://schemas.microsoft.com/office/drawing/2010/main" xmlns="" w="9525">
+                <a14:hiddenLine xmlns="" xmlns:a14="http://schemas.microsoft.com/office/drawing/2010/main" w="9525">
                   <a:solidFill>
                     <a:srgbClr val="000000"/>
                   </a:solidFill>
@@ -411,7 +411,7 @@
             </a:ln>
             <a:extLst>
               <a:ext uri="{91240B29-F687-4f45-9708-019B960494DF}">
-                <a14:hiddenLine xmlns:a14="http://schemas.microsoft.com/office/drawing/2010/main" xmlns="" w="9525">
+                <a14:hiddenLine xmlns="" xmlns:a14="http://schemas.microsoft.com/office/drawing/2010/main" w="9525">
                   <a:solidFill>
                     <a:srgbClr val="000000"/>
                   </a:solidFill>
@@ -445,7 +445,7 @@
             </a:ln>
             <a:extLst>
               <a:ext uri="{91240B29-F687-4f45-9708-019B960494DF}">
-                <a14:hiddenLine xmlns:a14="http://schemas.microsoft.com/office/drawing/2010/main" xmlns="" w="9525">
+                <a14:hiddenLine xmlns="" xmlns:a14="http://schemas.microsoft.com/office/drawing/2010/main" w="9525">
                   <a:solidFill>
                     <a:srgbClr val="000000"/>
                   </a:solidFill>
@@ -535,7 +535,7 @@
             </a:ln>
             <a:extLst>
               <a:ext uri="{91240B29-F687-4f45-9708-019B960494DF}">
-                <a14:hiddenLine xmlns:a14="http://schemas.microsoft.com/office/drawing/2010/main" xmlns="" w="9525">
+                <a14:hiddenLine xmlns="" xmlns:a14="http://schemas.microsoft.com/office/drawing/2010/main" w="9525">
                   <a:solidFill>
                     <a:srgbClr val="000000"/>
                   </a:solidFill>
@@ -597,7 +597,7 @@
             </a:ln>
             <a:extLst>
               <a:ext uri="{91240B29-F687-4f45-9708-019B960494DF}">
-                <a14:hiddenLine xmlns:a14="http://schemas.microsoft.com/office/drawing/2010/main" xmlns="" w="9525">
+                <a14:hiddenLine xmlns="" xmlns:a14="http://schemas.microsoft.com/office/drawing/2010/main" w="9525">
                   <a:solidFill>
                     <a:srgbClr val="000000"/>
                   </a:solidFill>
@@ -659,7 +659,7 @@
             </a:ln>
             <a:extLst>
               <a:ext uri="{91240B29-F687-4f45-9708-019B960494DF}">
-                <a14:hiddenLine xmlns:a14="http://schemas.microsoft.com/office/drawing/2010/main" xmlns="" w="9525">
+                <a14:hiddenLine xmlns="" xmlns:a14="http://schemas.microsoft.com/office/drawing/2010/main" w="9525">
                   <a:solidFill>
                     <a:srgbClr val="000000"/>
                   </a:solidFill>
@@ -749,7 +749,7 @@
             </a:ln>
             <a:extLst>
               <a:ext uri="{91240B29-F687-4f45-9708-019B960494DF}">
-                <a14:hiddenLine xmlns:a14="http://schemas.microsoft.com/office/drawing/2010/main" xmlns="" w="9525">
+                <a14:hiddenLine xmlns="" xmlns:a14="http://schemas.microsoft.com/office/drawing/2010/main" w="9525">
                   <a:solidFill>
                     <a:srgbClr val="000000"/>
                   </a:solidFill>
@@ -811,7 +811,7 @@
             </a:ln>
             <a:extLst>
               <a:ext uri="{91240B29-F687-4f45-9708-019B960494DF}">
-                <a14:hiddenLine xmlns:a14="http://schemas.microsoft.com/office/drawing/2010/main" xmlns="" w="9525">
+                <a14:hiddenLine xmlns="" xmlns:a14="http://schemas.microsoft.com/office/drawing/2010/main" w="9525">
                   <a:solidFill>
                     <a:srgbClr val="000000"/>
                   </a:solidFill>
@@ -873,7 +873,7 @@
             </a:ln>
             <a:extLst>
               <a:ext uri="{91240B29-F687-4f45-9708-019B960494DF}">
-                <a14:hiddenLine xmlns:a14="http://schemas.microsoft.com/office/drawing/2010/main" xmlns="" w="9525">
+                <a14:hiddenLine xmlns="" xmlns:a14="http://schemas.microsoft.com/office/drawing/2010/main" w="9525">
                   <a:solidFill>
                     <a:srgbClr val="000000"/>
                   </a:solidFill>
@@ -963,7 +963,7 @@
             </a:ln>
             <a:extLst>
               <a:ext uri="{91240B29-F687-4f45-9708-019B960494DF}">
-                <a14:hiddenLine xmlns:a14="http://schemas.microsoft.com/office/drawing/2010/main" xmlns="" w="9525">
+                <a14:hiddenLine xmlns="" xmlns:a14="http://schemas.microsoft.com/office/drawing/2010/main" w="9525">
                   <a:solidFill>
                     <a:srgbClr val="000000"/>
                   </a:solidFill>
@@ -1053,7 +1053,7 @@
             </a:ln>
             <a:extLst>
               <a:ext uri="{91240B29-F687-4f45-9708-019B960494DF}">
-                <a14:hiddenLine xmlns:a14="http://schemas.microsoft.com/office/drawing/2010/main" xmlns="" w="9525">
+                <a14:hiddenLine xmlns="" xmlns:a14="http://schemas.microsoft.com/office/drawing/2010/main" w="9525">
                   <a:solidFill>
                     <a:srgbClr val="000000"/>
                   </a:solidFill>
@@ -1115,7 +1115,7 @@
             </a:ln>
             <a:extLst>
               <a:ext uri="{91240B29-F687-4f45-9708-019B960494DF}">
-                <a14:hiddenLine xmlns:a14="http://schemas.microsoft.com/office/drawing/2010/main" xmlns="" w="9525">
+                <a14:hiddenLine xmlns="" xmlns:a14="http://schemas.microsoft.com/office/drawing/2010/main" w="9525">
                   <a:solidFill>
                     <a:srgbClr val="000000"/>
                   </a:solidFill>
@@ -1225,7 +1225,7 @@
             </a:ln>
             <a:extLst>
               <a:ext uri="{91240B29-F687-4f45-9708-019B960494DF}">
-                <a14:hiddenLine xmlns:a14="http://schemas.microsoft.com/office/drawing/2010/main" xmlns="" w="9525">
+                <a14:hiddenLine xmlns="" xmlns:a14="http://schemas.microsoft.com/office/drawing/2010/main" w="9525">
                   <a:solidFill>
                     <a:srgbClr val="000000"/>
                   </a:solidFill>
@@ -1287,7 +1287,7 @@
             </a:ln>
             <a:extLst>
               <a:ext uri="{91240B29-F687-4f45-9708-019B960494DF}">
-                <a14:hiddenLine xmlns:a14="http://schemas.microsoft.com/office/drawing/2010/main" xmlns="" w="9525">
+                <a14:hiddenLine xmlns="" xmlns:a14="http://schemas.microsoft.com/office/drawing/2010/main" w="9525">
                   <a:solidFill>
                     <a:srgbClr val="000000"/>
                   </a:solidFill>
@@ -1377,7 +1377,7 @@
             </a:ln>
             <a:extLst>
               <a:ext uri="{91240B29-F687-4f45-9708-019B960494DF}">
-                <a14:hiddenLine xmlns:a14="http://schemas.microsoft.com/office/drawing/2010/main" xmlns="" w="9525">
+                <a14:hiddenLine xmlns="" xmlns:a14="http://schemas.microsoft.com/office/drawing/2010/main" w="9525">
                   <a:solidFill>
                     <a:srgbClr val="000000"/>
                   </a:solidFill>
@@ -1467,7 +1467,7 @@
             </a:ln>
             <a:extLst>
               <a:ext uri="{91240B29-F687-4f45-9708-019B960494DF}">
-                <a14:hiddenLine xmlns:a14="http://schemas.microsoft.com/office/drawing/2010/main" xmlns="" w="9525">
+                <a14:hiddenLine xmlns="" xmlns:a14="http://schemas.microsoft.com/office/drawing/2010/main" w="9525">
                   <a:solidFill>
                     <a:srgbClr val="000000"/>
                   </a:solidFill>
@@ -1529,7 +1529,7 @@
             </a:ln>
             <a:extLst>
               <a:ext uri="{91240B29-F687-4f45-9708-019B960494DF}">
-                <a14:hiddenLine xmlns:a14="http://schemas.microsoft.com/office/drawing/2010/main" xmlns="" w="9525">
+                <a14:hiddenLine xmlns="" xmlns:a14="http://schemas.microsoft.com/office/drawing/2010/main" w="9525">
                   <a:solidFill>
                     <a:srgbClr val="000000"/>
                   </a:solidFill>
@@ -1619,7 +1619,7 @@
             </a:ln>
             <a:extLst>
               <a:ext uri="{91240B29-F687-4f45-9708-019B960494DF}">
-                <a14:hiddenLine xmlns:a14="http://schemas.microsoft.com/office/drawing/2010/main" xmlns="" w="9525">
+                <a14:hiddenLine xmlns="" xmlns:a14="http://schemas.microsoft.com/office/drawing/2010/main" w="9525">
                   <a:solidFill>
                     <a:srgbClr val="000000"/>
                   </a:solidFill>
@@ -1709,7 +1709,7 @@
             </a:ln>
             <a:extLst>
               <a:ext uri="{91240B29-F687-4f45-9708-019B960494DF}">
-                <a14:hiddenLine xmlns:a14="http://schemas.microsoft.com/office/drawing/2010/main" xmlns="" w="9525">
+                <a14:hiddenLine xmlns="" xmlns:a14="http://schemas.microsoft.com/office/drawing/2010/main" w="9525">
                   <a:solidFill>
                     <a:srgbClr val="000000"/>
                   </a:solidFill>
@@ -1765,7 +1765,7 @@
             </a:ln>
             <a:extLst>
               <a:ext uri="{91240B29-F687-4f45-9708-019B960494DF}">
-                <a14:hiddenLine xmlns:a14="http://schemas.microsoft.com/office/drawing/2010/main" xmlns="" w="9525">
+                <a14:hiddenLine xmlns="" xmlns:a14="http://schemas.microsoft.com/office/drawing/2010/main" w="9525">
                   <a:solidFill>
                     <a:srgbClr val="000000"/>
                   </a:solidFill>
@@ -1855,7 +1855,7 @@
             </a:ln>
             <a:extLst>
               <a:ext uri="{91240B29-F687-4f45-9708-019B960494DF}">
-                <a14:hiddenLine xmlns:a14="http://schemas.microsoft.com/office/drawing/2010/main" xmlns="" w="9525">
+                <a14:hiddenLine xmlns="" xmlns:a14="http://schemas.microsoft.com/office/drawing/2010/main" w="9525">
                   <a:solidFill>
                     <a:srgbClr val="000000"/>
                   </a:solidFill>
@@ -1911,7 +1911,7 @@
             </a:ln>
             <a:extLst>
               <a:ext uri="{91240B29-F687-4f45-9708-019B960494DF}">
-                <a14:hiddenLine xmlns:a14="http://schemas.microsoft.com/office/drawing/2010/main" xmlns="" w="9525">
+                <a14:hiddenLine xmlns="" xmlns:a14="http://schemas.microsoft.com/office/drawing/2010/main" w="9525">
                   <a:solidFill>
                     <a:srgbClr val="000000"/>
                   </a:solidFill>
@@ -2001,7 +2001,7 @@
             </a:ln>
             <a:extLst>
               <a:ext uri="{91240B29-F687-4f45-9708-019B960494DF}">
-                <a14:hiddenLine xmlns:a14="http://schemas.microsoft.com/office/drawing/2010/main" xmlns="" w="9525">
+                <a14:hiddenLine xmlns="" xmlns:a14="http://schemas.microsoft.com/office/drawing/2010/main" w="9525">
                   <a:solidFill>
                     <a:srgbClr val="000000"/>
                   </a:solidFill>
@@ -2069,7 +2069,7 @@
             </a:ln>
             <a:extLst>
               <a:ext uri="{91240B29-F687-4f45-9708-019B960494DF}">
-                <a14:hiddenLine xmlns:a14="http://schemas.microsoft.com/office/drawing/2010/main" xmlns="" w="9525">
+                <a14:hiddenLine xmlns="" xmlns:a14="http://schemas.microsoft.com/office/drawing/2010/main" w="9525">
                   <a:solidFill>
                     <a:srgbClr val="000000"/>
                   </a:solidFill>
@@ -2159,7 +2159,7 @@
             </a:ln>
             <a:extLst>
               <a:ext uri="{91240B29-F687-4f45-9708-019B960494DF}">
-                <a14:hiddenLine xmlns:a14="http://schemas.microsoft.com/office/drawing/2010/main" xmlns="" w="9525">
+                <a14:hiddenLine xmlns="" xmlns:a14="http://schemas.microsoft.com/office/drawing/2010/main" w="9525">
                   <a:solidFill>
                     <a:srgbClr val="000000"/>
                   </a:solidFill>
@@ -2227,7 +2227,7 @@
             </a:ln>
             <a:extLst>
               <a:ext uri="{91240B29-F687-4f45-9708-019B960494DF}">
-                <a14:hiddenLine xmlns:a14="http://schemas.microsoft.com/office/drawing/2010/main" xmlns="" w="9525">
+                <a14:hiddenLine xmlns="" xmlns:a14="http://schemas.microsoft.com/office/drawing/2010/main" w="9525">
                   <a:solidFill>
                     <a:srgbClr val="000000"/>
                   </a:solidFill>
@@ -2317,7 +2317,7 @@
             </a:ln>
             <a:extLst>
               <a:ext uri="{91240B29-F687-4f45-9708-019B960494DF}">
-                <a14:hiddenLine xmlns:a14="http://schemas.microsoft.com/office/drawing/2010/main" xmlns="" w="9525">
+                <a14:hiddenLine xmlns="" xmlns:a14="http://schemas.microsoft.com/office/drawing/2010/main" w="9525">
                   <a:solidFill>
                     <a:srgbClr val="000000"/>
                   </a:solidFill>
@@ -2351,7 +2351,7 @@
             </a:ln>
             <a:extLst>
               <a:ext uri="{91240B29-F687-4f45-9708-019B960494DF}">
-                <a14:hiddenLine xmlns:a14="http://schemas.microsoft.com/office/drawing/2010/main" xmlns="" w="9525">
+                <a14:hiddenLine xmlns="" xmlns:a14="http://schemas.microsoft.com/office/drawing/2010/main" w="9525">
                   <a:solidFill>
                     <a:srgbClr val="000000"/>
                   </a:solidFill>
@@ -2441,7 +2441,7 @@
             </a:ln>
             <a:extLst>
               <a:ext uri="{91240B29-F687-4f45-9708-019B960494DF}">
-                <a14:hiddenLine xmlns:a14="http://schemas.microsoft.com/office/drawing/2010/main" xmlns="" w="9525">
+                <a14:hiddenLine xmlns="" xmlns:a14="http://schemas.microsoft.com/office/drawing/2010/main" w="9525">
                   <a:solidFill>
                     <a:srgbClr val="000000"/>
                   </a:solidFill>
@@ -2503,7 +2503,7 @@
             </a:ln>
             <a:extLst>
               <a:ext uri="{91240B29-F687-4f45-9708-019B960494DF}">
-                <a14:hiddenLine xmlns:a14="http://schemas.microsoft.com/office/drawing/2010/main" xmlns="" w="9525">
+                <a14:hiddenLine xmlns="" xmlns:a14="http://schemas.microsoft.com/office/drawing/2010/main" w="9525">
                   <a:solidFill>
                     <a:srgbClr val="000000"/>
                   </a:solidFill>
@@ -2565,7 +2565,7 @@
             </a:ln>
             <a:extLst>
               <a:ext uri="{91240B29-F687-4f45-9708-019B960494DF}">
-                <a14:hiddenLine xmlns:a14="http://schemas.microsoft.com/office/drawing/2010/main" xmlns="" w="9525">
+                <a14:hiddenLine xmlns="" xmlns:a14="http://schemas.microsoft.com/office/drawing/2010/main" w="9525">
                   <a:solidFill>
                     <a:srgbClr val="000000"/>
                   </a:solidFill>
@@ -2655,7 +2655,7 @@
             </a:ln>
             <a:extLst>
               <a:ext uri="{91240B29-F687-4f45-9708-019B960494DF}">
-                <a14:hiddenLine xmlns:a14="http://schemas.microsoft.com/office/drawing/2010/main" xmlns="" w="9525">
+                <a14:hiddenLine xmlns="" xmlns:a14="http://schemas.microsoft.com/office/drawing/2010/main" w="9525">
                   <a:solidFill>
                     <a:srgbClr val="000000"/>
                   </a:solidFill>
@@ -2723,7 +2723,7 @@
             </a:ln>
             <a:extLst>
               <a:ext uri="{91240B29-F687-4f45-9708-019B960494DF}">
-                <a14:hiddenLine xmlns:a14="http://schemas.microsoft.com/office/drawing/2010/main" xmlns="" w="9525">
+                <a14:hiddenLine xmlns="" xmlns:a14="http://schemas.microsoft.com/office/drawing/2010/main" w="9525">
                   <a:solidFill>
                     <a:srgbClr val="000000"/>
                   </a:solidFill>
@@ -2785,7 +2785,7 @@
             </a:ln>
             <a:extLst>
               <a:ext uri="{91240B29-F687-4f45-9708-019B960494DF}">
-                <a14:hiddenLine xmlns:a14="http://schemas.microsoft.com/office/drawing/2010/main" xmlns="" w="9525">
+                <a14:hiddenLine xmlns="" xmlns:a14="http://schemas.microsoft.com/office/drawing/2010/main" w="9525">
                   <a:solidFill>
                     <a:srgbClr val="000000"/>
                   </a:solidFill>
@@ -2875,7 +2875,7 @@
             </a:ln>
             <a:extLst>
               <a:ext uri="{91240B29-F687-4f45-9708-019B960494DF}">
-                <a14:hiddenLine xmlns:a14="http://schemas.microsoft.com/office/drawing/2010/main" xmlns="" w="9525">
+                <a14:hiddenLine xmlns="" xmlns:a14="http://schemas.microsoft.com/office/drawing/2010/main" w="9525">
                   <a:solidFill>
                     <a:srgbClr val="000000"/>
                   </a:solidFill>
@@ -2937,7 +2937,7 @@
             </a:ln>
             <a:extLst>
               <a:ext uri="{91240B29-F687-4f45-9708-019B960494DF}">
-                <a14:hiddenLine xmlns:a14="http://schemas.microsoft.com/office/drawing/2010/main" xmlns="" w="9525">
+                <a14:hiddenLine xmlns="" xmlns:a14="http://schemas.microsoft.com/office/drawing/2010/main" w="9525">
                   <a:solidFill>
                     <a:srgbClr val="000000"/>
                   </a:solidFill>
@@ -3027,7 +3027,7 @@
             </a:ln>
             <a:extLst>
               <a:ext uri="{91240B29-F687-4f45-9708-019B960494DF}">
-                <a14:hiddenLine xmlns:a14="http://schemas.microsoft.com/office/drawing/2010/main" xmlns="" w="9525">
+                <a14:hiddenLine xmlns="" xmlns:a14="http://schemas.microsoft.com/office/drawing/2010/main" w="9525">
                   <a:solidFill>
                     <a:srgbClr val="000000"/>
                   </a:solidFill>
@@ -3089,7 +3089,7 @@
             </a:ln>
             <a:extLst>
               <a:ext uri="{91240B29-F687-4f45-9708-019B960494DF}">
-                <a14:hiddenLine xmlns:a14="http://schemas.microsoft.com/office/drawing/2010/main" xmlns="" w="9525">
+                <a14:hiddenLine xmlns="" xmlns:a14="http://schemas.microsoft.com/office/drawing/2010/main" w="9525">
                   <a:solidFill>
                     <a:srgbClr val="000000"/>
                   </a:solidFill>
@@ -3179,7 +3179,7 @@
             </a:ln>
             <a:extLst>
               <a:ext uri="{91240B29-F687-4f45-9708-019B960494DF}">
-                <a14:hiddenLine xmlns:a14="http://schemas.microsoft.com/office/drawing/2010/main" xmlns="" w="9525">
+                <a14:hiddenLine xmlns="" xmlns:a14="http://schemas.microsoft.com/office/drawing/2010/main" w="9525">
                   <a:solidFill>
                     <a:srgbClr val="000000"/>
                   </a:solidFill>
@@ -3213,7 +3213,7 @@
             </a:ln>
             <a:extLst>
               <a:ext uri="{91240B29-F687-4f45-9708-019B960494DF}">
-                <a14:hiddenLine xmlns:a14="http://schemas.microsoft.com/office/drawing/2010/main" xmlns="" w="9525">
+                <a14:hiddenLine xmlns="" xmlns:a14="http://schemas.microsoft.com/office/drawing/2010/main" w="9525">
                   <a:solidFill>
                     <a:srgbClr val="000000"/>
                   </a:solidFill>
@@ -3278,7 +3278,7 @@
             </a:ln>
             <a:extLst>
               <a:ext uri="{91240B29-F687-4f45-9708-019B960494DF}">
-                <a14:hiddenLine xmlns:a14="http://schemas.microsoft.com/office/drawing/2010/main" xmlns="" w="9525">
+                <a14:hiddenLine xmlns="" xmlns:a14="http://schemas.microsoft.com/office/drawing/2010/main" w="9525">
                   <a:solidFill>
                     <a:srgbClr val="000000"/>
                   </a:solidFill>
@@ -3368,7 +3368,7 @@
             </a:ln>
             <a:extLst>
               <a:ext uri="{91240B29-F687-4f45-9708-019B960494DF}">
-                <a14:hiddenLine xmlns:a14="http://schemas.microsoft.com/office/drawing/2010/main" xmlns="" w="9525">
+                <a14:hiddenLine xmlns="" xmlns:a14="http://schemas.microsoft.com/office/drawing/2010/main" w="9525">
                   <a:solidFill>
                     <a:srgbClr val="000000"/>
                   </a:solidFill>
@@ -3430,7 +3430,7 @@
             </a:ln>
             <a:extLst>
               <a:ext uri="{91240B29-F687-4f45-9708-019B960494DF}">
-                <a14:hiddenLine xmlns:a14="http://schemas.microsoft.com/office/drawing/2010/main" xmlns="" w="9525">
+                <a14:hiddenLine xmlns="" xmlns:a14="http://schemas.microsoft.com/office/drawing/2010/main" w="9525">
                   <a:solidFill>
                     <a:srgbClr val="000000"/>
                   </a:solidFill>
@@ -3520,7 +3520,7 @@
             </a:ln>
             <a:extLst>
               <a:ext uri="{91240B29-F687-4f45-9708-019B960494DF}">
-                <a14:hiddenLine xmlns:a14="http://schemas.microsoft.com/office/drawing/2010/main" xmlns="" w="9525">
+                <a14:hiddenLine xmlns="" xmlns:a14="http://schemas.microsoft.com/office/drawing/2010/main" w="9525">
                   <a:solidFill>
                     <a:srgbClr val="000000"/>
                   </a:solidFill>
@@ -3610,7 +3610,7 @@
             </a:ln>
             <a:extLst>
               <a:ext uri="{91240B29-F687-4f45-9708-019B960494DF}">
-                <a14:hiddenLine xmlns:a14="http://schemas.microsoft.com/office/drawing/2010/main" xmlns="" w="9525">
+                <a14:hiddenLine xmlns="" xmlns:a14="http://schemas.microsoft.com/office/drawing/2010/main" w="9525">
                   <a:solidFill>
                     <a:srgbClr val="000000"/>
                   </a:solidFill>
@@ -3675,7 +3675,7 @@
             </a:ln>
             <a:extLst>
               <a:ext uri="{91240B29-F687-4f45-9708-019B960494DF}">
-                <a14:hiddenLine xmlns:a14="http://schemas.microsoft.com/office/drawing/2010/main" xmlns="" w="9525">
+                <a14:hiddenLine xmlns="" xmlns:a14="http://schemas.microsoft.com/office/drawing/2010/main" w="9525">
                   <a:solidFill>
                     <a:srgbClr val="000000"/>
                   </a:solidFill>
@@ -3737,7 +3737,7 @@
             </a:ln>
             <a:extLst>
               <a:ext uri="{91240B29-F687-4f45-9708-019B960494DF}">
-                <a14:hiddenLine xmlns:a14="http://schemas.microsoft.com/office/drawing/2010/main" xmlns="" w="9525">
+                <a14:hiddenLine xmlns="" xmlns:a14="http://schemas.microsoft.com/office/drawing/2010/main" w="9525">
                   <a:solidFill>
                     <a:srgbClr val="000000"/>
                   </a:solidFill>
@@ -3827,7 +3827,7 @@
             </a:ln>
             <a:extLst>
               <a:ext uri="{91240B29-F687-4f45-9708-019B960494DF}">
-                <a14:hiddenLine xmlns:a14="http://schemas.microsoft.com/office/drawing/2010/main" xmlns="" w="9525">
+                <a14:hiddenLine xmlns="" xmlns:a14="http://schemas.microsoft.com/office/drawing/2010/main" w="9525">
                   <a:solidFill>
                     <a:srgbClr val="000000"/>
                   </a:solidFill>
@@ -3917,7 +3917,7 @@
             </a:ln>
             <a:extLst>
               <a:ext uri="{91240B29-F687-4f45-9708-019B960494DF}">
-                <a14:hiddenLine xmlns:a14="http://schemas.microsoft.com/office/drawing/2010/main" xmlns="" w="9525">
+                <a14:hiddenLine xmlns="" xmlns:a14="http://schemas.microsoft.com/office/drawing/2010/main" w="9525">
                   <a:solidFill>
                     <a:srgbClr val="000000"/>
                   </a:solidFill>
@@ -3979,7 +3979,7 @@
             </a:ln>
             <a:extLst>
               <a:ext uri="{91240B29-F687-4f45-9708-019B960494DF}">
-                <a14:hiddenLine xmlns:a14="http://schemas.microsoft.com/office/drawing/2010/main" xmlns="" w="9525">
+                <a14:hiddenLine xmlns="" xmlns:a14="http://schemas.microsoft.com/office/drawing/2010/main" w="9525">
                   <a:solidFill>
                     <a:srgbClr val="000000"/>
                   </a:solidFill>
@@ -4099,7 +4099,7 @@
             </a:ln>
             <a:extLst>
               <a:ext uri="{91240B29-F687-4f45-9708-019B960494DF}">
-                <a14:hiddenLine xmlns:a14="http://schemas.microsoft.com/office/drawing/2010/main" xmlns="" w="9525">
+                <a14:hiddenLine xmlns="" xmlns:a14="http://schemas.microsoft.com/office/drawing/2010/main" w="9525">
                   <a:solidFill>
                     <a:srgbClr val="000000"/>
                   </a:solidFill>
@@ -4167,7 +4167,7 @@
             </a:ln>
             <a:extLst>
               <a:ext uri="{91240B29-F687-4f45-9708-019B960494DF}">
-                <a14:hiddenLine xmlns:a14="http://schemas.microsoft.com/office/drawing/2010/main" xmlns="" w="9525">
+                <a14:hiddenLine xmlns="" xmlns:a14="http://schemas.microsoft.com/office/drawing/2010/main" w="9525">
                   <a:solidFill>
                     <a:srgbClr val="000000"/>
                   </a:solidFill>
@@ -4257,7 +4257,7 @@
             </a:ln>
             <a:extLst>
               <a:ext uri="{91240B29-F687-4f45-9708-019B960494DF}">
-                <a14:hiddenLine xmlns:a14="http://schemas.microsoft.com/office/drawing/2010/main" xmlns="" w="9525">
+                <a14:hiddenLine xmlns="" xmlns:a14="http://schemas.microsoft.com/office/drawing/2010/main" w="9525">
                   <a:solidFill>
                     <a:srgbClr val="000000"/>
                   </a:solidFill>
@@ -4397,7 +4397,7 @@
           <a:p>
             <a:fld id="{E6C53141-58E6-457F-8CA1-783506B9F67B}" type="datetimeFigureOut">
               <a:rPr lang="en-IN" smtClean="0"/>
-              <a:t>07-03-2026</a:t>
+              <a:t>09-03-2026</a:t>
             </a:fld>
             <a:endParaRPr lang="en-IN"/>
           </a:p>
@@ -4664,7 +4664,7 @@
           <a:p>
             <a:fld id="{E6C53141-58E6-457F-8CA1-783506B9F67B}" type="datetimeFigureOut">
               <a:rPr lang="en-IN" smtClean="0"/>
-              <a:t>07-03-2026</a:t>
+              <a:t>09-03-2026</a:t>
             </a:fld>
             <a:endParaRPr lang="en-IN"/>
           </a:p>
@@ -4860,7 +4860,7 @@
           <a:p>
             <a:fld id="{E6C53141-58E6-457F-8CA1-783506B9F67B}" type="datetimeFigureOut">
               <a:rPr lang="en-IN" smtClean="0"/>
-              <a:t>07-03-2026</a:t>
+              <a:t>09-03-2026</a:t>
             </a:fld>
             <a:endParaRPr lang="en-IN"/>
           </a:p>
@@ -5123,7 +5123,7 @@
           <a:p>
             <a:fld id="{E6C53141-58E6-457F-8CA1-783506B9F67B}" type="datetimeFigureOut">
               <a:rPr lang="en-IN" smtClean="0"/>
-              <a:t>07-03-2026</a:t>
+              <a:t>09-03-2026</a:t>
             </a:fld>
             <a:endParaRPr lang="en-IN"/>
           </a:p>
@@ -5557,7 +5557,7 @@
           <a:p>
             <a:fld id="{E6C53141-58E6-457F-8CA1-783506B9F67B}" type="datetimeFigureOut">
               <a:rPr lang="en-IN" smtClean="0"/>
-              <a:t>07-03-2026</a:t>
+              <a:t>09-03-2026</a:t>
             </a:fld>
             <a:endParaRPr lang="en-IN"/>
           </a:p>
@@ -6103,7 +6103,7 @@
           <a:p>
             <a:fld id="{E6C53141-58E6-457F-8CA1-783506B9F67B}" type="datetimeFigureOut">
               <a:rPr lang="en-IN" smtClean="0"/>
-              <a:t>07-03-2026</a:t>
+              <a:t>09-03-2026</a:t>
             </a:fld>
             <a:endParaRPr lang="en-IN"/>
           </a:p>
@@ -6823,7 +6823,7 @@
           <a:p>
             <a:fld id="{E6C53141-58E6-457F-8CA1-783506B9F67B}" type="datetimeFigureOut">
               <a:rPr lang="en-IN" smtClean="0"/>
-              <a:t>07-03-2026</a:t>
+              <a:t>09-03-2026</a:t>
             </a:fld>
             <a:endParaRPr lang="en-IN"/>
           </a:p>
@@ -6993,7 +6993,7 @@
           <a:p>
             <a:fld id="{E6C53141-58E6-457F-8CA1-783506B9F67B}" type="datetimeFigureOut">
               <a:rPr lang="en-IN" smtClean="0"/>
-              <a:t>07-03-2026</a:t>
+              <a:t>09-03-2026</a:t>
             </a:fld>
             <a:endParaRPr lang="en-IN"/>
           </a:p>
@@ -7173,7 +7173,7 @@
           <a:p>
             <a:fld id="{E6C53141-58E6-457F-8CA1-783506B9F67B}" type="datetimeFigureOut">
               <a:rPr lang="en-IN" smtClean="0"/>
-              <a:t>07-03-2026</a:t>
+              <a:t>09-03-2026</a:t>
             </a:fld>
             <a:endParaRPr lang="en-IN"/>
           </a:p>
@@ -7343,7 +7343,7 @@
           <a:p>
             <a:fld id="{E6C53141-58E6-457F-8CA1-783506B9F67B}" type="datetimeFigureOut">
               <a:rPr lang="en-IN" smtClean="0"/>
-              <a:t>07-03-2026</a:t>
+              <a:t>09-03-2026</a:t>
             </a:fld>
             <a:endParaRPr lang="en-IN"/>
           </a:p>
@@ -7593,7 +7593,7 @@
           <a:p>
             <a:fld id="{E6C53141-58E6-457F-8CA1-783506B9F67B}" type="datetimeFigureOut">
               <a:rPr lang="en-IN" smtClean="0"/>
-              <a:t>07-03-2026</a:t>
+              <a:t>09-03-2026</a:t>
             </a:fld>
             <a:endParaRPr lang="en-IN"/>
           </a:p>
@@ -7825,7 +7825,7 @@
           <a:p>
             <a:fld id="{E6C53141-58E6-457F-8CA1-783506B9F67B}" type="datetimeFigureOut">
               <a:rPr lang="en-IN" smtClean="0"/>
-              <a:t>07-03-2026</a:t>
+              <a:t>09-03-2026</a:t>
             </a:fld>
             <a:endParaRPr lang="en-IN"/>
           </a:p>
@@ -8206,7 +8206,7 @@
           <a:p>
             <a:fld id="{E6C53141-58E6-457F-8CA1-783506B9F67B}" type="datetimeFigureOut">
               <a:rPr lang="en-IN" smtClean="0"/>
-              <a:t>07-03-2026</a:t>
+              <a:t>09-03-2026</a:t>
             </a:fld>
             <a:endParaRPr lang="en-IN"/>
           </a:p>
@@ -8324,7 +8324,7 @@
           <a:p>
             <a:fld id="{E6C53141-58E6-457F-8CA1-783506B9F67B}" type="datetimeFigureOut">
               <a:rPr lang="en-IN" smtClean="0"/>
-              <a:t>07-03-2026</a:t>
+              <a:t>09-03-2026</a:t>
             </a:fld>
             <a:endParaRPr lang="en-IN"/>
           </a:p>
@@ -8419,7 +8419,7 @@
           <a:p>
             <a:fld id="{E6C53141-58E6-457F-8CA1-783506B9F67B}" type="datetimeFigureOut">
               <a:rPr lang="en-IN" smtClean="0"/>
-              <a:t>07-03-2026</a:t>
+              <a:t>09-03-2026</a:t>
             </a:fld>
             <a:endParaRPr lang="en-IN"/>
           </a:p>
@@ -8668,7 +8668,7 @@
           <a:p>
             <a:fld id="{E6C53141-58E6-457F-8CA1-783506B9F67B}" type="datetimeFigureOut">
               <a:rPr lang="en-IN" smtClean="0"/>
-              <a:t>07-03-2026</a:t>
+              <a:t>09-03-2026</a:t>
             </a:fld>
             <a:endParaRPr lang="en-IN"/>
           </a:p>
@@ -8948,7 +8948,7 @@
           <a:p>
             <a:fld id="{E6C53141-58E6-457F-8CA1-783506B9F67B}" type="datetimeFigureOut">
               <a:rPr lang="en-IN" smtClean="0"/>
-              <a:t>07-03-2026</a:t>
+              <a:t>09-03-2026</a:t>
             </a:fld>
             <a:endParaRPr lang="en-IN"/>
           </a:p>
@@ -9064,7 +9064,7 @@
           <a:noFill/>
           <a:extLst>
             <a:ext uri="{909E8E84-426E-40dd-AFC4-6F175D3DCCD1}">
-              <a14:hiddenFill xmlns:a14="http://schemas.microsoft.com/office/drawing/2010/main" xmlns="">
+              <a14:hiddenFill xmlns="" xmlns:a14="http://schemas.microsoft.com/office/drawing/2010/main">
                 <a:solidFill>
                   <a:srgbClr val="FFFFFF"/>
                 </a:solidFill>
@@ -9138,7 +9138,7 @@
               </a:ln>
               <a:extLst>
                 <a:ext uri="{91240B29-F687-4f45-9708-019B960494DF}">
-                  <a14:hiddenLine xmlns:a14="http://schemas.microsoft.com/office/drawing/2010/main" xmlns="" w="9525">
+                  <a14:hiddenLine xmlns="" xmlns:a14="http://schemas.microsoft.com/office/drawing/2010/main" w="9525">
                     <a:solidFill>
                       <a:srgbClr val="000000"/>
                     </a:solidFill>
@@ -9228,7 +9228,7 @@
               </a:ln>
               <a:extLst>
                 <a:ext uri="{91240B29-F687-4f45-9708-019B960494DF}">
-                  <a14:hiddenLine xmlns:a14="http://schemas.microsoft.com/office/drawing/2010/main" xmlns="" w="9525">
+                  <a14:hiddenLine xmlns="" xmlns:a14="http://schemas.microsoft.com/office/drawing/2010/main" w="9525">
                     <a:solidFill>
                       <a:srgbClr val="000000"/>
                     </a:solidFill>
@@ -9318,7 +9318,7 @@
               </a:ln>
               <a:extLst>
                 <a:ext uri="{91240B29-F687-4f45-9708-019B960494DF}">
-                  <a14:hiddenLine xmlns:a14="http://schemas.microsoft.com/office/drawing/2010/main" xmlns="" w="9525">
+                  <a14:hiddenLine xmlns="" xmlns:a14="http://schemas.microsoft.com/office/drawing/2010/main" w="9525">
                     <a:solidFill>
                       <a:srgbClr val="000000"/>
                     </a:solidFill>
@@ -9380,7 +9380,7 @@
               </a:ln>
               <a:extLst>
                 <a:ext uri="{91240B29-F687-4f45-9708-019B960494DF}">
-                  <a14:hiddenLine xmlns:a14="http://schemas.microsoft.com/office/drawing/2010/main" xmlns="" w="9525">
+                  <a14:hiddenLine xmlns="" xmlns:a14="http://schemas.microsoft.com/office/drawing/2010/main" w="9525">
                     <a:solidFill>
                       <a:srgbClr val="000000"/>
                     </a:solidFill>
@@ -9470,7 +9470,7 @@
               </a:ln>
               <a:extLst>
                 <a:ext uri="{91240B29-F687-4f45-9708-019B960494DF}">
-                  <a14:hiddenLine xmlns:a14="http://schemas.microsoft.com/office/drawing/2010/main" xmlns="" w="9525">
+                  <a14:hiddenLine xmlns="" xmlns:a14="http://schemas.microsoft.com/office/drawing/2010/main" w="9525">
                     <a:solidFill>
                       <a:srgbClr val="000000"/>
                     </a:solidFill>
@@ -9532,7 +9532,7 @@
               </a:ln>
               <a:extLst>
                 <a:ext uri="{91240B29-F687-4f45-9708-019B960494DF}">
-                  <a14:hiddenLine xmlns:a14="http://schemas.microsoft.com/office/drawing/2010/main" xmlns="" w="9525">
+                  <a14:hiddenLine xmlns="" xmlns:a14="http://schemas.microsoft.com/office/drawing/2010/main" w="9525">
                     <a:solidFill>
                       <a:srgbClr val="000000"/>
                     </a:solidFill>
@@ -9594,7 +9594,7 @@
               </a:ln>
               <a:extLst>
                 <a:ext uri="{91240B29-F687-4f45-9708-019B960494DF}">
-                  <a14:hiddenLine xmlns:a14="http://schemas.microsoft.com/office/drawing/2010/main" xmlns="" w="9525">
+                  <a14:hiddenLine xmlns="" xmlns:a14="http://schemas.microsoft.com/office/drawing/2010/main" w="9525">
                     <a:solidFill>
                       <a:srgbClr val="000000"/>
                     </a:solidFill>
@@ -9684,7 +9684,7 @@
               </a:ln>
               <a:extLst>
                 <a:ext uri="{91240B29-F687-4f45-9708-019B960494DF}">
-                  <a14:hiddenLine xmlns:a14="http://schemas.microsoft.com/office/drawing/2010/main" xmlns="" w="9525">
+                  <a14:hiddenLine xmlns="" xmlns:a14="http://schemas.microsoft.com/office/drawing/2010/main" w="9525">
                     <a:solidFill>
                       <a:srgbClr val="000000"/>
                     </a:solidFill>
@@ -9774,7 +9774,7 @@
               </a:ln>
               <a:extLst>
                 <a:ext uri="{91240B29-F687-4f45-9708-019B960494DF}">
-                  <a14:hiddenLine xmlns:a14="http://schemas.microsoft.com/office/drawing/2010/main" xmlns="" w="9525">
+                  <a14:hiddenLine xmlns="" xmlns:a14="http://schemas.microsoft.com/office/drawing/2010/main" w="9525">
                     <a:solidFill>
                       <a:srgbClr val="000000"/>
                     </a:solidFill>
@@ -9836,7 +9836,7 @@
               </a:ln>
               <a:extLst>
                 <a:ext uri="{91240B29-F687-4f45-9708-019B960494DF}">
-                  <a14:hiddenLine xmlns:a14="http://schemas.microsoft.com/office/drawing/2010/main" xmlns="" w="9525">
+                  <a14:hiddenLine xmlns="" xmlns:a14="http://schemas.microsoft.com/office/drawing/2010/main" w="9525">
                     <a:solidFill>
                       <a:srgbClr val="000000"/>
                     </a:solidFill>
@@ -9946,7 +9946,7 @@
               </a:ln>
               <a:extLst>
                 <a:ext uri="{91240B29-F687-4f45-9708-019B960494DF}">
-                  <a14:hiddenLine xmlns:a14="http://schemas.microsoft.com/office/drawing/2010/main" xmlns="" w="9525">
+                  <a14:hiddenLine xmlns="" xmlns:a14="http://schemas.microsoft.com/office/drawing/2010/main" w="9525">
                     <a:solidFill>
                       <a:srgbClr val="000000"/>
                     </a:solidFill>
@@ -10030,7 +10030,7 @@
               </a:ln>
               <a:extLst>
                 <a:ext uri="{91240B29-F687-4f45-9708-019B960494DF}">
-                  <a14:hiddenLine xmlns:a14="http://schemas.microsoft.com/office/drawing/2010/main" xmlns="" w="9525">
+                  <a14:hiddenLine xmlns="" xmlns:a14="http://schemas.microsoft.com/office/drawing/2010/main" w="9525">
                     <a:solidFill>
                       <a:srgbClr val="000000"/>
                     </a:solidFill>
@@ -10092,7 +10092,7 @@
               </a:ln>
               <a:extLst>
                 <a:ext uri="{91240B29-F687-4f45-9708-019B960494DF}">
-                  <a14:hiddenLine xmlns:a14="http://schemas.microsoft.com/office/drawing/2010/main" xmlns="" w="9525">
+                  <a14:hiddenLine xmlns="" xmlns:a14="http://schemas.microsoft.com/office/drawing/2010/main" w="9525">
                     <a:solidFill>
                       <a:srgbClr val="000000"/>
                     </a:solidFill>
@@ -10154,7 +10154,7 @@
               </a:ln>
               <a:extLst>
                 <a:ext uri="{91240B29-F687-4f45-9708-019B960494DF}">
-                  <a14:hiddenLine xmlns:a14="http://schemas.microsoft.com/office/drawing/2010/main" xmlns="" w="9525">
+                  <a14:hiddenLine xmlns="" xmlns:a14="http://schemas.microsoft.com/office/drawing/2010/main" w="9525">
                     <a:solidFill>
                       <a:srgbClr val="000000"/>
                     </a:solidFill>
@@ -10244,7 +10244,7 @@
               </a:ln>
               <a:extLst>
                 <a:ext uri="{91240B29-F687-4f45-9708-019B960494DF}">
-                  <a14:hiddenLine xmlns:a14="http://schemas.microsoft.com/office/drawing/2010/main" xmlns="" w="9525">
+                  <a14:hiddenLine xmlns="" xmlns:a14="http://schemas.microsoft.com/office/drawing/2010/main" w="9525">
                     <a:solidFill>
                       <a:srgbClr val="000000"/>
                     </a:solidFill>
@@ -10278,7 +10278,7 @@
               </a:ln>
               <a:extLst>
                 <a:ext uri="{91240B29-F687-4f45-9708-019B960494DF}">
-                  <a14:hiddenLine xmlns:a14="http://schemas.microsoft.com/office/drawing/2010/main" xmlns="" w="9525">
+                  <a14:hiddenLine xmlns="" xmlns:a14="http://schemas.microsoft.com/office/drawing/2010/main" w="9525">
                     <a:solidFill>
                       <a:srgbClr val="000000"/>
                     </a:solidFill>
@@ -10343,7 +10343,7 @@
               </a:ln>
               <a:extLst>
                 <a:ext uri="{91240B29-F687-4f45-9708-019B960494DF}">
-                  <a14:hiddenLine xmlns:a14="http://schemas.microsoft.com/office/drawing/2010/main" xmlns="" w="9525">
+                  <a14:hiddenLine xmlns="" xmlns:a14="http://schemas.microsoft.com/office/drawing/2010/main" w="9525">
                     <a:solidFill>
                       <a:srgbClr val="000000"/>
                     </a:solidFill>
@@ -10433,7 +10433,7 @@
               </a:ln>
               <a:extLst>
                 <a:ext uri="{91240B29-F687-4f45-9708-019B960494DF}">
-                  <a14:hiddenLine xmlns:a14="http://schemas.microsoft.com/office/drawing/2010/main" xmlns="" w="9525">
+                  <a14:hiddenLine xmlns="" xmlns:a14="http://schemas.microsoft.com/office/drawing/2010/main" w="9525">
                     <a:solidFill>
                       <a:srgbClr val="000000"/>
                     </a:solidFill>
@@ -10495,7 +10495,7 @@
               </a:ln>
               <a:extLst>
                 <a:ext uri="{91240B29-F687-4f45-9708-019B960494DF}">
-                  <a14:hiddenLine xmlns:a14="http://schemas.microsoft.com/office/drawing/2010/main" xmlns="" w="9525">
+                  <a14:hiddenLine xmlns="" xmlns:a14="http://schemas.microsoft.com/office/drawing/2010/main" w="9525">
                     <a:solidFill>
                       <a:srgbClr val="000000"/>
                     </a:solidFill>
@@ -10585,7 +10585,7 @@
               </a:ln>
               <a:extLst>
                 <a:ext uri="{91240B29-F687-4f45-9708-019B960494DF}">
-                  <a14:hiddenLine xmlns:a14="http://schemas.microsoft.com/office/drawing/2010/main" xmlns="" w="9525">
+                  <a14:hiddenLine xmlns="" xmlns:a14="http://schemas.microsoft.com/office/drawing/2010/main" w="9525">
                     <a:solidFill>
                       <a:srgbClr val="000000"/>
                     </a:solidFill>
@@ -10650,7 +10650,7 @@
               </a:ln>
               <a:extLst>
                 <a:ext uri="{91240B29-F687-4f45-9708-019B960494DF}">
-                  <a14:hiddenLine xmlns:a14="http://schemas.microsoft.com/office/drawing/2010/main" xmlns="" w="9525">
+                  <a14:hiddenLine xmlns="" xmlns:a14="http://schemas.microsoft.com/office/drawing/2010/main" w="9525">
                     <a:solidFill>
                       <a:srgbClr val="000000"/>
                     </a:solidFill>
@@ -10712,7 +10712,7 @@
               </a:ln>
               <a:extLst>
                 <a:ext uri="{91240B29-F687-4f45-9708-019B960494DF}">
-                  <a14:hiddenLine xmlns:a14="http://schemas.microsoft.com/office/drawing/2010/main" xmlns="" w="9525">
+                  <a14:hiddenLine xmlns="" xmlns:a14="http://schemas.microsoft.com/office/drawing/2010/main" w="9525">
                     <a:solidFill>
                       <a:srgbClr val="000000"/>
                     </a:solidFill>
@@ -10802,7 +10802,7 @@
               </a:ln>
               <a:extLst>
                 <a:ext uri="{91240B29-F687-4f45-9708-019B960494DF}">
-                  <a14:hiddenLine xmlns:a14="http://schemas.microsoft.com/office/drawing/2010/main" xmlns="" w="9525">
+                  <a14:hiddenLine xmlns="" xmlns:a14="http://schemas.microsoft.com/office/drawing/2010/main" w="9525">
                     <a:solidFill>
                       <a:srgbClr val="000000"/>
                     </a:solidFill>
@@ -10892,7 +10892,7 @@
               </a:ln>
               <a:extLst>
                 <a:ext uri="{91240B29-F687-4f45-9708-019B960494DF}">
-                  <a14:hiddenLine xmlns:a14="http://schemas.microsoft.com/office/drawing/2010/main" xmlns="" w="9525">
+                  <a14:hiddenLine xmlns="" xmlns:a14="http://schemas.microsoft.com/office/drawing/2010/main" w="9525">
                     <a:solidFill>
                       <a:srgbClr val="000000"/>
                     </a:solidFill>
@@ -10957,7 +10957,7 @@
               </a:ln>
               <a:extLst>
                 <a:ext uri="{91240B29-F687-4f45-9708-019B960494DF}">
-                  <a14:hiddenLine xmlns:a14="http://schemas.microsoft.com/office/drawing/2010/main" xmlns="" w="9525">
+                  <a14:hiddenLine xmlns="" xmlns:a14="http://schemas.microsoft.com/office/drawing/2010/main" w="9525">
                     <a:solidFill>
                       <a:srgbClr val="000000"/>
                     </a:solidFill>
@@ -11077,7 +11077,7 @@
               </a:ln>
               <a:extLst>
                 <a:ext uri="{91240B29-F687-4f45-9708-019B960494DF}">
-                  <a14:hiddenLine xmlns:a14="http://schemas.microsoft.com/office/drawing/2010/main" xmlns="" w="9525">
+                  <a14:hiddenLine xmlns="" xmlns:a14="http://schemas.microsoft.com/office/drawing/2010/main" w="9525">
                     <a:solidFill>
                       <a:srgbClr val="000000"/>
                     </a:solidFill>
@@ -11175,7 +11175,7 @@
               </a:ln>
               <a:extLst>
                 <a:ext uri="{91240B29-F687-4f45-9708-019B960494DF}">
-                  <a14:hiddenLine xmlns:a14="http://schemas.microsoft.com/office/drawing/2010/main" xmlns="" w="9525">
+                  <a14:hiddenLine xmlns="" xmlns:a14="http://schemas.microsoft.com/office/drawing/2010/main" w="9525">
                     <a:solidFill>
                       <a:srgbClr val="000000"/>
                     </a:solidFill>
@@ -11290,7 +11290,7 @@
               </a:ln>
               <a:extLst>
                 <a:ext uri="{91240B29-F687-4f45-9708-019B960494DF}">
-                  <a14:hiddenLine xmlns:a14="http://schemas.microsoft.com/office/drawing/2010/main" xmlns="" w="9525">
+                  <a14:hiddenLine xmlns="" xmlns:a14="http://schemas.microsoft.com/office/drawing/2010/main" w="9525">
                     <a:solidFill>
                       <a:srgbClr val="000000"/>
                     </a:solidFill>
@@ -11380,7 +11380,7 @@
               </a:ln>
               <a:extLst>
                 <a:ext uri="{91240B29-F687-4f45-9708-019B960494DF}">
-                  <a14:hiddenLine xmlns:a14="http://schemas.microsoft.com/office/drawing/2010/main" xmlns="" w="9525">
+                  <a14:hiddenLine xmlns="" xmlns:a14="http://schemas.microsoft.com/office/drawing/2010/main" w="9525">
                     <a:solidFill>
                       <a:srgbClr val="000000"/>
                     </a:solidFill>
@@ -11445,7 +11445,7 @@
               </a:ln>
               <a:extLst>
                 <a:ext uri="{91240B29-F687-4f45-9708-019B960494DF}">
-                  <a14:hiddenLine xmlns:a14="http://schemas.microsoft.com/office/drawing/2010/main" xmlns="" w="9525">
+                  <a14:hiddenLine xmlns="" xmlns:a14="http://schemas.microsoft.com/office/drawing/2010/main" w="9525">
                     <a:solidFill>
                       <a:srgbClr val="000000"/>
                     </a:solidFill>
@@ -11535,7 +11535,7 @@
               </a:ln>
               <a:extLst>
                 <a:ext uri="{91240B29-F687-4f45-9708-019B960494DF}">
-                  <a14:hiddenLine xmlns:a14="http://schemas.microsoft.com/office/drawing/2010/main" xmlns="" w="9525">
+                  <a14:hiddenLine xmlns="" xmlns:a14="http://schemas.microsoft.com/office/drawing/2010/main" w="9525">
                     <a:solidFill>
                       <a:srgbClr val="000000"/>
                     </a:solidFill>
@@ -11603,7 +11603,7 @@
               </a:ln>
               <a:extLst>
                 <a:ext uri="{91240B29-F687-4f45-9708-019B960494DF}">
-                  <a14:hiddenLine xmlns:a14="http://schemas.microsoft.com/office/drawing/2010/main" xmlns="" w="9525">
+                  <a14:hiddenLine xmlns="" xmlns:a14="http://schemas.microsoft.com/office/drawing/2010/main" w="9525">
                     <a:solidFill>
                       <a:srgbClr val="000000"/>
                     </a:solidFill>
@@ -11693,7 +11693,7 @@
               </a:ln>
               <a:extLst>
                 <a:ext uri="{91240B29-F687-4f45-9708-019B960494DF}">
-                  <a14:hiddenLine xmlns:a14="http://schemas.microsoft.com/office/drawing/2010/main" xmlns="" w="9525">
+                  <a14:hiddenLine xmlns="" xmlns:a14="http://schemas.microsoft.com/office/drawing/2010/main" w="9525">
                     <a:solidFill>
                       <a:srgbClr val="000000"/>
                     </a:solidFill>
@@ -11761,7 +11761,7 @@
               </a:ln>
               <a:extLst>
                 <a:ext uri="{91240B29-F687-4f45-9708-019B960494DF}">
-                  <a14:hiddenLine xmlns:a14="http://schemas.microsoft.com/office/drawing/2010/main" xmlns="" w="9525">
+                  <a14:hiddenLine xmlns="" xmlns:a14="http://schemas.microsoft.com/office/drawing/2010/main" w="9525">
                     <a:solidFill>
                       <a:srgbClr val="000000"/>
                     </a:solidFill>
@@ -11851,7 +11851,7 @@
               </a:ln>
               <a:extLst>
                 <a:ext uri="{91240B29-F687-4f45-9708-019B960494DF}">
-                  <a14:hiddenLine xmlns:a14="http://schemas.microsoft.com/office/drawing/2010/main" xmlns="" w="9525">
+                  <a14:hiddenLine xmlns="" xmlns:a14="http://schemas.microsoft.com/office/drawing/2010/main" w="9525">
                     <a:solidFill>
                       <a:srgbClr val="000000"/>
                     </a:solidFill>
@@ -11885,7 +11885,7 @@
               </a:ln>
               <a:extLst>
                 <a:ext uri="{91240B29-F687-4f45-9708-019B960494DF}">
-                  <a14:hiddenLine xmlns:a14="http://schemas.microsoft.com/office/drawing/2010/main" xmlns="" w="9525">
+                  <a14:hiddenLine xmlns="" xmlns:a14="http://schemas.microsoft.com/office/drawing/2010/main" w="9525">
                     <a:solidFill>
                       <a:srgbClr val="000000"/>
                     </a:solidFill>
@@ -12025,7 +12025,7 @@
           <a:p>
             <a:fld id="{E6C53141-58E6-457F-8CA1-783506B9F67B}" type="datetimeFigureOut">
               <a:rPr lang="en-IN" smtClean="0"/>
-              <a:t>07-03-2026</a:t>
+              <a:t>09-03-2026</a:t>
             </a:fld>
             <a:endParaRPr lang="en-IN"/>
           </a:p>
@@ -14818,8 +14818,8 @@
         </p:blipFill>
         <p:spPr>
           <a:xfrm>
-            <a:off x="1583201" y="1699465"/>
-            <a:ext cx="9214938" cy="4859676"/>
+            <a:off x="1583201" y="1533832"/>
+            <a:ext cx="9214938" cy="5025309"/>
           </a:xfrm>
         </p:spPr>
       </p:pic>

</xml_diff>